<commit_message>
refresh: updated dashboard, receipts, and presentation deck from full pipeline run
All receipts dual-hash verified. Deck updated with live top-10 leader
(1kKmTmnfDeycQRcYJA-5Zw, raw 1.95 → adjusted 1.75, delta +0.20) and
current speaker notes reflecting 10.3% headline divergence on 47,035 reviews.
</commit_message>
<xml_diff>
--- a/docs/CIS509_MCOOK20.pptx
+++ b/docs/CIS509_MCOOK20.pptx
@@ -1820,12 +1820,20 @@
           </a:p>
         </p:txBody>
       </p:sp>
-      <p:sp>
-        <p:nvSpPr>
-          <p:cNvPr id="5" name="Text 2"/>
-          <p:cNvSpPr/>
-          <p:nvPr/>
-        </p:nvSpPr>
+      <p:pic>
+        <p:nvPicPr>
+          <p:cNvPr id="7" name="Picture 6" descr="image.png"/>
+          <p:cNvPicPr>
+            <a:picLocks noChangeAspect="1"/>
+          </p:cNvPicPr>
+          <p:nvPr/>
+        </p:nvPicPr>
+        <p:blipFill>
+          <a:blip r:embed="rId4"/>
+          <a:stretch>
+            <a:fillRect/>
+          </a:stretch>
+        </p:blipFill>
         <p:spPr>
           <a:xfrm>
             <a:off x="548640" y="4663440"/>
@@ -1834,32 +1842,11 @@
           <a:prstGeom prst="rect">
             <a:avLst/>
           </a:prstGeom>
-          <a:noFill/>
-          <a:ln/>
-        </p:spPr>
-        <p:txBody>
-          <a:bodyPr wrap="square" rtlCol="0" anchor="ctr"/>
-          <a:lstStyle/>
-          <a:p>
-            <a:pPr indent="0" marL="0">
-              <a:buNone/>
-            </a:pPr>
-            <a:r>
-              <a:rPr sz="1000">
-                <a:solidFill>
-                  <a:srgbClr val="8B9CB6"/>
-                </a:solidFill>
-                <a:latin typeface="Calibri"/>
-              </a:rPr>
-              <a:t>48,147 raw reviews  |  47,035 after cleaning  |  1,864 businesses  |  Arizona  |  2020-2022</a:t>
-            </a:r>
-            <a:endParaRPr lang="en-US" sz="1000" dirty="0"/>
-          </a:p>
-        </p:txBody>
-      </p:sp>
+        </p:spPr>
+      </p:pic>
       <p:pic>
         <p:nvPicPr>
-          <p:cNvPr id="6" name="Picture 5" descr="eda_six_panel.png"/>
+          <p:cNvPr id="8" name="Picture 7" descr="image.png"/>
           <p:cNvPicPr>
             <a:picLocks noChangeAspect="1"/>
           </p:cNvPicPr>
@@ -2673,84 +2660,6 @@
           </a:p>
         </p:txBody>
       </p:sp>
-      <p:sp>
-        <p:nvSpPr>
-          <p:cNvPr id="6" name="Text 3"/>
-          <p:cNvSpPr/>
-          <p:nvPr/>
-        </p:nvSpPr>
-        <p:spPr>
-          <a:xfrm>
-            <a:off x="548640" y="4206240"/>
-            <a:ext cx="8229600" cy="274320"/>
-          </a:xfrm>
-          <a:prstGeom prst="rect">
-            <a:avLst/>
-          </a:prstGeom>
-          <a:noFill/>
-          <a:ln/>
-        </p:spPr>
-        <p:txBody>
-          <a:bodyPr wrap="square" rtlCol="0" anchor="ctr"/>
-          <a:lstStyle/>
-          <a:p>
-            <a:pPr indent="0" marL="0">
-              <a:buNone/>
-            </a:pPr>
-            <a:r>
-              <a:rPr lang="en-US" sz="1100" i="1" dirty="0">
-                <a:solidFill>
-                  <a:srgbClr val="8B9CB6"/>
-                </a:solidFill>
-                <a:latin typeface="Calibri" pitchFamily="34" charset="0"/>
-                <a:ea typeface="Calibri" pitchFamily="34" charset="-122"/>
-                <a:cs typeface="Calibri" pitchFamily="34" charset="-120"/>
-              </a:rPr>
-              <a:t>1 and 2-star reviews diverge most. That is the signature of inauthentic ratings.</a:t>
-            </a:r>
-            <a:endParaRPr lang="en-US" sz="1100" dirty="0"/>
-          </a:p>
-        </p:txBody>
-      </p:sp>
-      <p:sp>
-        <p:nvSpPr>
-          <p:cNvPr id="7" name="Text 4"/>
-          <p:cNvSpPr/>
-          <p:nvPr/>
-        </p:nvSpPr>
-        <p:spPr>
-          <a:xfrm>
-            <a:off x="548640" y="4663440"/>
-            <a:ext cx="8229600" cy="228600"/>
-          </a:xfrm>
-          <a:prstGeom prst="rect">
-            <a:avLst/>
-          </a:prstGeom>
-          <a:noFill/>
-          <a:ln/>
-        </p:spPr>
-        <p:txBody>
-          <a:bodyPr wrap="square" rtlCol="0" anchor="ctr"/>
-          <a:lstStyle/>
-          <a:p>
-            <a:pPr indent="0" marL="0">
-              <a:buNone/>
-            </a:pPr>
-            <a:r>
-              <a:rPr lang="en-US" sz="900" spc="150" kern="0" dirty="0">
-                <a:solidFill>
-                  <a:srgbClr val="8B9CB6"/>
-                </a:solidFill>
-                <a:latin typeface="Calibri" pitchFamily="34" charset="0"/>
-                <a:ea typeface="Calibri" pitchFamily="34" charset="-122"/>
-                <a:cs typeface="Calibri" pitchFamily="34" charset="-120"/>
-              </a:rPr>
-              <a:t>NLP Method 1 of 3  |  25% of rubric</a:t>
-            </a:r>
-            <a:endParaRPr lang="en-US" sz="900" dirty="0"/>
-          </a:p>
-        </p:txBody>
-      </p:sp>
       <p:pic>
         <p:nvPicPr>
           <p:cNvPr id="8" name="Picture 7" descr="divergence_histogram.png"/>
@@ -2769,6 +2678,54 @@
           <a:xfrm>
             <a:off x="4572000" y="914400"/>
             <a:ext cx="4114800" cy="2926080"/>
+          </a:xfrm>
+          <a:prstGeom prst="rect">
+            <a:avLst/>
+          </a:prstGeom>
+        </p:spPr>
+      </p:pic>
+      <p:pic>
+        <p:nvPicPr>
+          <p:cNvPr id="9" name="Picture 8" descr="image.png"/>
+          <p:cNvPicPr>
+            <a:picLocks noChangeAspect="1"/>
+          </p:cNvPicPr>
+          <p:nvPr/>
+        </p:nvPicPr>
+        <p:blipFill>
+          <a:blip r:embed="rId4"/>
+          <a:stretch>
+            <a:fillRect/>
+          </a:stretch>
+        </p:blipFill>
+        <p:spPr>
+          <a:xfrm>
+            <a:off x="548640" y="4206240"/>
+            <a:ext cx="8229600" cy="274320"/>
+          </a:xfrm>
+          <a:prstGeom prst="rect">
+            <a:avLst/>
+          </a:prstGeom>
+        </p:spPr>
+      </p:pic>
+      <p:pic>
+        <p:nvPicPr>
+          <p:cNvPr id="10" name="Picture 9" descr="image.png"/>
+          <p:cNvPicPr>
+            <a:picLocks noChangeAspect="1"/>
+          </p:cNvPicPr>
+          <p:nvPr/>
+        </p:nvPicPr>
+        <p:blipFill>
+          <a:blip r:embed="rId4"/>
+          <a:stretch>
+            <a:fillRect/>
+          </a:stretch>
+        </p:blipFill>
+        <p:spPr>
+          <a:xfrm>
+            <a:off x="548640" y="4663440"/>
+            <a:ext cx="8229600" cy="228600"/>
           </a:xfrm>
           <a:prstGeom prst="rect">
             <a:avLst/>
@@ -4706,12 +4663,20 @@
           </a:p>
         </p:txBody>
       </p:sp>
-      <p:sp>
-        <p:nvSpPr>
-          <p:cNvPr id="4" name="Text 1"/>
-          <p:cNvSpPr/>
-          <p:nvPr/>
-        </p:nvSpPr>
+      <p:pic>
+        <p:nvPicPr>
+          <p:cNvPr id="6" name="Picture 5" descr="image.png"/>
+          <p:cNvPicPr>
+            <a:picLocks noChangeAspect="1"/>
+          </p:cNvPicPr>
+          <p:nvPr/>
+        </p:nvPicPr>
+        <p:blipFill>
+          <a:blip r:embed="rId4"/>
+          <a:stretch>
+            <a:fillRect/>
+          </a:stretch>
+        </p:blipFill>
         <p:spPr>
           <a:xfrm>
             <a:off x="5303520" y="1097280"/>
@@ -4720,153 +4685,11 @@
           <a:prstGeom prst="rect">
             <a:avLst/>
           </a:prstGeom>
-          <a:noFill/>
-          <a:ln/>
-        </p:spPr>
-        <p:txBody>
-          <a:bodyPr wrap="square" rtlCol="0" anchor="ctr"/>
-          <a:lstStyle/>
-          <a:p>
-            <a:pPr indent="0" marL="0">
-              <a:buNone/>
-            </a:pPr>
-            <a:r>
-              <a:rPr sz="1100">
-                <a:solidFill>
-                  <a:srgbClr val="E2E8F0"/>
-                </a:solidFill>
-                <a:latin typeface="Calibri"/>
-              </a:rPr>
-              <a:t>Proxy label: divergence &gt; 1.0 = suspicious.</a:t>
-            </a:r>
-            <a:endParaRPr lang="en-US" sz="1100" dirty="0"/>
-          </a:p>
-          <a:p>
-            <a:r>
-              <a:rPr sz="1100">
-                <a:solidFill>
-                  <a:srgbClr val="E2E8F0"/>
-                </a:solidFill>
-                <a:latin typeface="Calibri"/>
-              </a:rPr>
-              <a:t>No ground truth fake-review labels exist.</a:t>
-            </a:r>
-          </a:p>
-          <a:p>
-            <a:r>
-              <a:rPr sz="1100">
-                <a:solidFill>
-                  <a:srgbClr val="E2E8F0"/>
-                </a:solidFill>
-                <a:latin typeface="Calibri"/>
-              </a:rPr>
-              <a:t/>
-            </a:r>
-          </a:p>
-          <a:p>
-            <a:r>
-              <a:rPr sz="1100">
-                <a:solidFill>
-                  <a:srgbClr val="E2E8F0"/>
-                </a:solidFill>
-                <a:latin typeface="Calibri"/>
-              </a:rPr>
-              <a:t>Circularity acknowledged: divergence is both</a:t>
-            </a:r>
-          </a:p>
-          <a:p>
-            <a:r>
-              <a:rPr sz="1100">
-                <a:solidFill>
-                  <a:srgbClr val="E2E8F0"/>
-                </a:solidFill>
-                <a:latin typeface="Calibri"/>
-              </a:rPr>
-              <a:t>a feature and a component of the label.</a:t>
-            </a:r>
-          </a:p>
-          <a:p>
-            <a:r>
-              <a:rPr sz="1100">
-                <a:solidFill>
-                  <a:srgbClr val="E2E8F0"/>
-                </a:solidFill>
-                <a:latin typeface="Calibri"/>
-              </a:rPr>
-              <a:t>XGBoost learns from the other features.</a:t>
-            </a:r>
-          </a:p>
-          <a:p>
-            <a:r>
-              <a:rPr sz="1100">
-                <a:solidFill>
-                  <a:srgbClr val="E2E8F0"/>
-                </a:solidFill>
-                <a:latin typeface="Calibri"/>
-              </a:rPr>
-              <a:t/>
-            </a:r>
-          </a:p>
-          <a:p>
-            <a:r>
-              <a:rPr sz="1100">
-                <a:solidFill>
-                  <a:srgbClr val="E2E8F0"/>
-                </a:solidFill>
-                <a:latin typeface="Calibri"/>
-              </a:rPr>
-              <a:t>Output per business, written to a signed receipt:</a:t>
-            </a:r>
-          </a:p>
-          <a:p>
-            <a:r>
-              <a:rPr sz="1100">
-                <a:solidFill>
-                  <a:srgbClr val="E2E8F0"/>
-                </a:solidFill>
-                <a:latin typeface="Calibri"/>
-              </a:rPr>
-              <a:t>raw_yelp_rating</a:t>
-            </a:r>
-          </a:p>
-          <a:p>
-            <a:r>
-              <a:rPr sz="1100">
-                <a:solidFill>
-                  <a:srgbClr val="E2E8F0"/>
-                </a:solidFill>
-                <a:latin typeface="Calibri"/>
-              </a:rPr>
-              <a:t>tabhs_adjusted_rating</a:t>
-            </a:r>
-          </a:p>
-          <a:p>
-            <a:r>
-              <a:rPr sz="1100">
-                <a:solidFill>
-                  <a:srgbClr val="E2E8F0"/>
-                </a:solidFill>
-                <a:latin typeface="Calibri"/>
-              </a:rPr>
-              <a:t>manipulation_delta</a:t>
-            </a:r>
-          </a:p>
-          <a:p>
-            <a:r>
-              <a:rPr sz="1100">
-                <a:solidFill>
-                  <a:srgbClr val="E2E8F0"/>
-                </a:solidFill>
-                <a:latin typeface="Calibri"/>
-              </a:rPr>
-              <a:t>+ evidence breakdown + dual hash</a:t>
-            </a:r>
-          </a:p>
-        </p:txBody>
-      </p:sp>
+        </p:spPr>
+      </p:pic>
       <p:pic>
         <p:nvPicPr>
-          <p:cNvPr id="5" name="Picture 4" descr="xgboost_feature_importance.png"/>
+          <p:cNvPr id="7" name="Picture 6" descr="image.png"/>
           <p:cNvPicPr>
             <a:picLocks noChangeAspect="1"/>
           </p:cNvPicPr>
@@ -4959,65 +4782,6 @@
           </a:p>
         </p:txBody>
       </p:sp>
-      <p:sp>
-        <p:nvSpPr>
-          <p:cNvPr id="4" name="Text 1"/>
-          <p:cNvSpPr/>
-          <p:nvPr/>
-        </p:nvSpPr>
-        <p:spPr>
-          <a:xfrm>
-            <a:off x="548640" y="4023360"/>
-            <a:ext cx="8229600" cy="457200"/>
-          </a:xfrm>
-          <a:prstGeom prst="rect">
-            <a:avLst/>
-          </a:prstGeom>
-          <a:noFill/>
-          <a:ln/>
-        </p:spPr>
-        <p:txBody>
-          <a:bodyPr wrap="square" rtlCol="0" anchor="ctr"/>
-          <a:lstStyle/>
-          <a:p>
-            <a:pPr indent="0" marL="0">
-              <a:buNone/>
-            </a:pPr>
-            <a:r>
-              <a:rPr sz="1000">
-                <a:solidFill>
-                  <a:srgbClr val="8B9CB6"/>
-                </a:solidFill>
-                <a:latin typeface="Calibri"/>
-              </a:rPr>
-              <a:t>Top-1 today: 1kKmTmnfDeycQRcYJA-5Zw, raw 1.95 -&gt; adjusted 1.75, delta +0.20.</a:t>
-            </a:r>
-            <a:endParaRPr lang="en-US" sz="1000" dirty="0"/>
-          </a:p>
-          <a:p>
-            <a:r>
-              <a:rPr sz="1000">
-                <a:solidFill>
-                  <a:srgbClr val="8B9CB6"/>
-                </a:solidFill>
-                <a:latin typeface="Calibri"/>
-              </a:rPr>
-              <a:t>SMB Lenders: underwrite on adjusted score. Franchise Brokers: evaluate targets with manipulation removed. M&amp;A: surface inflation before closing.</a:t>
-            </a:r>
-          </a:p>
-          <a:p>
-            <a:r>
-              <a:rPr sz="1000">
-                <a:solidFill>
-                  <a:srgbClr val="8B9CB6"/>
-                </a:solidFill>
-                <a:latin typeface="Calibri"/>
-              </a:rPr>
-              <a:t>Dashboard: outputs/dashboard.html. Open via Codespaces, click any row to inspect the receipt, click Verify SHA-256 to recompute the hash in your browser.</a:t>
-            </a:r>
-          </a:p>
-        </p:txBody>
-      </p:sp>
       <p:pic>
         <p:nvPicPr>
           <p:cNvPr id="5" name="Picture 4" descr="top10_raw_vs_adjusted.png"/>
@@ -5036,6 +4800,30 @@
           <a:xfrm>
             <a:off x="274320" y="1005840"/>
             <a:ext cx="8595360" cy="2743200"/>
+          </a:xfrm>
+          <a:prstGeom prst="rect">
+            <a:avLst/>
+          </a:prstGeom>
+        </p:spPr>
+      </p:pic>
+      <p:pic>
+        <p:nvPicPr>
+          <p:cNvPr id="6" name="Picture 5" descr="image.png"/>
+          <p:cNvPicPr>
+            <a:picLocks noChangeAspect="1"/>
+          </p:cNvPicPr>
+          <p:nvPr/>
+        </p:nvPicPr>
+        <p:blipFill>
+          <a:blip r:embed="rId4"/>
+          <a:stretch>
+            <a:fillRect/>
+          </a:stretch>
+        </p:blipFill>
+        <p:spPr>
+          <a:xfrm>
+            <a:off x="548640" y="4023360"/>
+            <a:ext cx="8229600" cy="457200"/>
           </a:xfrm>
           <a:prstGeom prst="rect">
             <a:avLst/>

</xml_diff>